<commit_message>
Chart colors: cu's campus (the roof tile, the sandstone map, sky over roofs), ncar's and ucar's vivid maps
livery_charts.py: charts.maps adds sequential color maps beside the ramps (or the generated
ones) without constraining the categorical selection; charts.sequential may name a map.
cu: the roof tile in sun, #9C3F29, sampled from the campus photo, is the third brand hue (CU's
web Brick #AE5A39 is too near CU Gold for a scatter, dE 13.5); the campus map (Light Gold, the
Flatirons' sandstone, the tile in sun and shade) is the default; the diverging scale is Sky Blue
to the tile. ncar: a map through the brand's blues, Light Blue's tints to Space, the default;
ucar the same along UCAR Aqua.

Co-Authored-By: Claude Opus 5.5 <noreply@anthropic.com>
Claude-Session: https://claude.ai/code/session_01QxTZPtUJESWqMyXE15JCRv
</commit_message>
<xml_diff>
--- a/liveries/cu/template.pptx
+++ b/liveries/cu/template.pptx
@@ -3218,23 +3218,23 @@
     <a:custClr name="Data 2 · Blue">
       <a:srgbClr val="096FAE"/>
     </a:custClr>
-    <a:custClr name="Data 3 · Brown">
-      <a:srgbClr val="7D4000"/>
+    <a:custClr name="Data 3 · Red">
+      <a:srgbClr val="9C3F29"/>
     </a:custClr>
     <a:custClr name="Data 4 · Teal">
       <a:srgbClr val="00A2AE"/>
     </a:custClr>
-    <a:custClr name="Data 5 · Magenta">
-      <a:srgbClr val="7A3270"/>
+    <a:custClr name="Data 5 · Blue">
+      <a:srgbClr val="334C98"/>
     </a:custClr>
-    <a:custClr name="Data 6 · Green">
-      <a:srgbClr val="6C7300"/>
+    <a:custClr name="Data 6 · Orange">
+      <a:srgbClr val="A86100"/>
     </a:custClr>
-    <a:custClr name="Data 7 · Blue">
-      <a:srgbClr val="6382D3"/>
+    <a:custClr name="Data 7 · Pink">
+      <a:srgbClr val="812F62"/>
     </a:custClr>
-    <a:custClr name="Data 8 · Teal">
-      <a:srgbClr val="007E67"/>
+    <a:custClr name="Data 8 · Pink">
+      <a:srgbClr val="BC5969"/>
     </a:custClr>
   </a:custClrLst>
 </a:theme>

</xml_diff>

<commit_message>
cu: sage as the fourth series hue; the plots deck's stacked area labelled by machine and queue
Sage (Ben's pick) #9CAF88 is held to its hue and raised to the chroma floor, #7A9C51 on white:
the series had no green. Atmosphere/Ocean/Land promised colors the families do not have (ncar's
Ocean is orange): the groups are machines now, the members their queues. Gallery rebuilt.

Co-Authored-By: Claude Opus 5.5 <noreply@anthropic.com>
Claude-Session: https://claude.ai/code/session_01QxTZPtUJESWqMyXE15JCRv
</commit_message>
<xml_diff>
--- a/liveries/cu/template.pptx
+++ b/liveries/cu/template.pptx
@@ -3215,26 +3215,26 @@
     <a:custClr name="Data 1 · Gold">
       <a:srgbClr val="AD8E38"/>
     </a:custClr>
-    <a:custClr name="Data 2 · Blue">
+    <a:custClr name="Data 2 · Red">
+      <a:srgbClr val="9C3F29"/>
+    </a:custClr>
+    <a:custClr name="Data 3 · Blue">
       <a:srgbClr val="096FAE"/>
     </a:custClr>
-    <a:custClr name="Data 3 · Red">
-      <a:srgbClr val="9C3F29"/>
+    <a:custClr name="Data 4 · Green">
+      <a:srgbClr val="7A9C51"/>
     </a:custClr>
-    <a:custClr name="Data 4 · Teal">
-      <a:srgbClr val="00A2AE"/>
+    <a:custClr name="Data 5 · Pink">
+      <a:srgbClr val="812F62"/>
     </a:custClr>
-    <a:custClr name="Data 5 · Blue">
+    <a:custClr name="Data 6 · Teal">
+      <a:srgbClr val="00A1B8"/>
+    </a:custClr>
+    <a:custClr name="Data 7 · Blue">
       <a:srgbClr val="334C98"/>
     </a:custClr>
-    <a:custClr name="Data 6 · Orange">
-      <a:srgbClr val="A86100"/>
-    </a:custClr>
-    <a:custClr name="Data 7 · Pink">
-      <a:srgbClr val="812F62"/>
-    </a:custClr>
-    <a:custClr name="Data 8 · Pink">
-      <a:srgbClr val="BC5969"/>
+    <a:custClr name="Data 8 · Teal">
+      <a:srgbClr val="008777"/>
     </a:custClr>
   </a:custClrLst>
 </a:theme>

</xml_diff>

<commit_message>
One look, one key: the themes' hand numbers as livery keys (the title band, hairline, gaps, footnotes, strip, tracking, on-dark) (#138)
</commit_message>
<xml_diff>
--- a/liveries/cu/template.pptx
+++ b/liveries/cu/template.pptx
@@ -115,7 +115,7 @@
                 <a:spcPts val="0"/>
               </a:spcBef>
               <a:buNone/>
-              <a:defRPr sz="2800" b="1" cap="all">
+              <a:defRPr sz="2800" b="1" cap="all" spc="224">
                 <a:solidFill>
                   <a:srgbClr val="000000"/>
                 </a:solidFill>
@@ -2349,7 +2349,7 @@
                 <a:spcPts val="0"/>
               </a:spcBef>
               <a:buNone/>
-              <a:defRPr sz="2800" b="1" cap="all">
+              <a:defRPr sz="2800" b="1" cap="all" spc="224">
                 <a:solidFill>
                   <a:srgbClr val="000000"/>
                 </a:solidFill>
@@ -2611,8 +2611,8 @@
         </p:nvSpPr>
         <p:spPr>
           <a:xfrm>
-            <a:off x="0" y="336042"/>
-            <a:ext cx="219456" cy="654253"/>
+            <a:off x="0" y="335356"/>
+            <a:ext cx="219456" cy="533552"/>
           </a:xfrm>
           <a:prstGeom prst="rect">
             <a:avLst/>
@@ -2639,11 +2639,9 @@
           <a:prstGeom prst="line">
             <a:avLst/>
           </a:prstGeom>
-          <a:ln w="9525">
+          <a:ln w="10973">
             <a:solidFill>
-              <a:schemeClr val="tx1">
-                <a:alpha val="30000"/>
-              </a:schemeClr>
+              <a:srgbClr val="AAA8A3"/>
             </a:solidFill>
           </a:ln>
         </p:spPr>
@@ -2660,8 +2658,8 @@
         </p:nvSpPr>
         <p:spPr>
           <a:xfrm>
-            <a:off x="731520" y="336042"/>
-            <a:ext cx="10728960" cy="654253"/>
+            <a:off x="731520" y="335356"/>
+            <a:ext cx="10728960" cy="533552"/>
           </a:xfrm>
           <a:prstGeom prst="rect">
             <a:avLst/>

</xml_diff>